<commit_message>
Rename remaining FtaCode references to BreakBite (AI log, archive, concepts)
</commit_message>
<xml_diff>
--- a/archive/slides-cu/Research_slides.pptx
+++ b/archive/slides-cu/Research_slides.pptx
@@ -1590,7 +1590,7 @@
                           <a:ea typeface="Plus Jakarta Sans" pitchFamily="34" charset="-122"/>
                           <a:cs typeface="Plus Jakarta Sans" pitchFamily="34" charset="-120"/>
                         </a:rPr>
-                        <a:t>Web FtaCode</a:t>
+                        <a:t>Web BreakBite</a:t>
                       </a:r>
                       <a:endParaRPr lang="en-US" sz="1200" dirty="0">
                         <a:latin typeface="Plus Jakarta Sans" charset="0"/>
@@ -1658,7 +1658,7 @@
                           <a:ea typeface="Plus Jakarta Sans" pitchFamily="34" charset="-122"/>
                           <a:cs typeface="Plus Jakarta Sans" pitchFamily="34" charset="-120"/>
                         </a:rPr>
-                        <a:t>FtaCode Mobile</a:t>
+                        <a:t>BreakBite</a:t>
                       </a:r>
                       <a:endParaRPr lang="en-US" sz="1200" dirty="0">
                         <a:latin typeface="Plus Jakarta Sans" charset="0"/>
@@ -3457,7 +3457,7 @@
                 <a:ea typeface="Plus Jakarta Sans" pitchFamily="34" charset="-122"/>
                 <a:cs typeface="Plus Jakarta Sans" pitchFamily="34" charset="-120"/>
               </a:rPr>
-              <a:t>Cột "Web FtaCode" lấy từ source frontend thật của quán. Mã A1–A5 là nhân vật trong phỏng vấn giả lập bằng AI (ai/ai-persona-interviews.md).</a:t>
+              <a:t>Cột "Web BreakBite" lấy từ source frontend thật của quán. Mã A1–A5 là nhân vật trong phỏng vấn giả lập bằng AI (ai/ai-persona-interviews.md).</a:t>
             </a:r>
             <a:endParaRPr lang="en-US" sz="1200" dirty="0"/>
           </a:p>

</xml_diff>